<commit_message>
update path in presentation
</commit_message>
<xml_diff>
--- a/Compile_safe_code_with_Visitor_pattern.pptx
+++ b/Compile_safe_code_with_Visitor_pattern.pptx
@@ -15812,7 +15812,7 @@
           </a:ln>
           <a:extLst>
             <a:ext uri="{C572A759-6A51-4108-AA02-DFA0A04FC94B}">
-              <ma14:wrappingTextBoxFlag xmlns:ma14="http://schemas.microsoft.com/office/mac/drawingml/2011/main" xmlns="" val="1"/>
+              <ma14:wrappingTextBoxFlag xmlns="" xmlns:ma14="http://schemas.microsoft.com/office/mac/drawingml/2011/main" val="1"/>
             </a:ext>
           </a:extLst>
         </p:spPr>
@@ -34239,7 +34239,7 @@
           </a:ln>
           <a:extLst>
             <a:ext uri="{C572A759-6A51-4108-AA02-DFA0A04FC94B}">
-              <ma14:wrappingTextBoxFlag xmlns="" xmlns:ma14="http://schemas.microsoft.com/office/mac/drawingml/2011/main" val="1"/>
+              <ma14:wrappingTextBoxFlag xmlns:ma14="http://schemas.microsoft.com/office/mac/drawingml/2011/main" xmlns="" val="1"/>
             </a:ext>
           </a:extLst>
         </p:spPr>
@@ -48218,10 +48218,10 @@
           <a:lstStyle/>
           <a:p>
             <a:r>
-              <a:rPr lang="en-US" dirty="0">
+              <a:rPr lang="en-US">
                 <a:hlinkClick r:id="rId2"/>
               </a:rPr>
-              <a:t>https://git.epam.com/gedotnet/design-patterns/dp-visitor-talk</a:t>
+              <a:t>https://git.epam.com/gedotnet/design-patterns/visitor</a:t>
             </a:r>
             <a:endParaRPr lang="ru-RU" dirty="0"/>
           </a:p>
@@ -50220,257 +50220,14 @@
 
 <file path=customXml/item1.xml><?xml version="1.0" encoding="utf-8"?>
 <?mso-contentType ?>
-<spe:Receivers xmlns:spe="http://schemas.microsoft.com/sharepoint/events">
-  <Receiver>
-    <Name>Document ID Generator</Name>
-    <Synchronization>Synchronous</Synchronization>
-    <Type>10001</Type>
-    <SequenceNumber>1000</SequenceNumber>
-    <Url/>
-    <Assembly>Microsoft.Office.DocumentManagement, Version=16.0.0.0, Culture=neutral, PublicKeyToken=71e9bce111e9429c</Assembly>
-    <Class>Microsoft.Office.DocumentManagement.Internal.DocIdHandler</Class>
-    <Data/>
-    <Filter/>
-  </Receiver>
-  <Receiver>
-    <Name>Document ID Generator</Name>
-    <Synchronization>Synchronous</Synchronization>
-    <Type>10002</Type>
-    <SequenceNumber>1001</SequenceNumber>
-    <Url/>
-    <Assembly>Microsoft.Office.DocumentManagement, Version=16.0.0.0, Culture=neutral, PublicKeyToken=71e9bce111e9429c</Assembly>
-    <Class>Microsoft.Office.DocumentManagement.Internal.DocIdHandler</Class>
-    <Data/>
-    <Filter/>
-  </Receiver>
-  <Receiver>
-    <Name>Document ID Generator</Name>
-    <Synchronization>Synchronous</Synchronization>
-    <Type>10004</Type>
-    <SequenceNumber>1002</SequenceNumber>
-    <Url/>
-    <Assembly>Microsoft.Office.DocumentManagement, Version=16.0.0.0, Culture=neutral, PublicKeyToken=71e9bce111e9429c</Assembly>
-    <Class>Microsoft.Office.DocumentManagement.Internal.DocIdHandler</Class>
-    <Data/>
-    <Filter/>
-  </Receiver>
-  <Receiver>
-    <Name>Document ID Generator</Name>
-    <Synchronization>Synchronous</Synchronization>
-    <Type>10006</Type>
-    <SequenceNumber>1003</SequenceNumber>
-    <Url/>
-    <Assembly>Microsoft.Office.DocumentManagement, Version=16.0.0.0, Culture=neutral, PublicKeyToken=71e9bce111e9429c</Assembly>
-    <Class>Microsoft.Office.DocumentManagement.Internal.DocIdHandler</Class>
-    <Data/>
-    <Filter/>
-  </Receiver>
-</spe:Receivers>
+<FormTemplates xmlns="http://schemas.microsoft.com/sharepoint/v3/contenttype/forms">
+  <Display>DocumentLibraryForm</Display>
+  <Edit>DocumentLibraryForm</Edit>
+  <New>DocumentLibraryForm</New>
+</FormTemplates>
 </file>
 
 <file path=customXml/item2.xml><?xml version="1.0" encoding="utf-8"?>
-<p:properties xmlns:p="http://schemas.microsoft.com/office/2006/metadata/properties" xmlns:xsi="http://www.w3.org/2001/XMLSchema-instance" xmlns:pc="http://schemas.microsoft.com/office/infopath/2007/PartnerControls">
-  <documentManagement>
-    <_dlc_DocIdPersistId xmlns="2f73596d-a490-4938-9ae7-6f2abd4edc7d" xsi:nil="true"/>
-    <_dlc_DocIdUrl xmlns="2f73596d-a490-4938-9ae7-6f2abd4edc7d">
-      <Url>https://epam.sharepoint.com/sites/policy/_layouts/15/DocIdRedir.aspx?ID=EPAM-1788376749-106</Url>
-      <Description>EPAM-1788376749-106</Description>
-    </_dlc_DocIdUrl>
-    <_dlc_DocId xmlns="2f73596d-a490-4938-9ae7-6f2abd4edc7d">EPAM-1788376749-106</_dlc_DocId>
-    <Company xmlns="http://schemas.microsoft.com/sharepoint/v3" xsi:nil="true"/>
-    <DocumentArea xmlns="a17c10a8-bd22-4f4b-9c5c-c3dc02494c46">
-      <Value>Maintenance and Support</Value>
-    </DocumentArea>
-    <Subarea xmlns="a17c10a8-bd22-4f4b-9c5c-c3dc02494c46">###</Subarea>
-    <Document_x0020_Approver_x0020__x0028_position_x0029_ xmlns="a17c10a8-bd22-4f4b-9c5c-c3dc02494c46">Senior Director, Delivery Management Office</Document_x0020_Approver_x0020__x0028_position_x0029_>
-    <Document_x0020_Owner_x0020__x0028_position_x0029_ xmlns="a17c10a8-bd22-4f4b-9c5c-c3dc02494c46">Head of Global Delivery</Document_x0020_Owner_x0020__x0028_position_x0029_>
-    <EPAMDocumentID_x0020_ xmlns="a17c10a8-bd22-4f4b-9c5c-c3dc02494c46">EPAM_Template-1203</EPAMDocumentID_x0020_>
-    <TemplatesTextContent xmlns="a17c10a8-bd22-4f4b-9c5c-c3dc02494c46">IT SERVICES MONTHLY REVIEW 
-Reported period : &lt;month, year &gt;
-CONFIDENTIAL  |  
-© 
-2024
- EPAM Systems, Inc.
-IT SERVICE HEALTH : SERVICE VOLUME
-&lt;Diagram with all user’s and monitoring  incidents during reported period ; including count of incidents and resolver assignment group&gt;
-IT SERVICE HEALTH : SERVICE VOLUME
-&lt;Diagram with all service requests during reported period, should include numbers of all INC and SRs tickets during this period.​
-Business meaning:​
-These numbers represent unique tasks that came to each team and required attention and effort.​
-Proposed actions / decisions:​
-Analyzing volume trends correlating with major events;​
-Volume spikes after major events may indicate the need for further research of systemic root causes. &gt;
-3
-Tower (top10)
-Created INC/SR during &lt;repot period&gt;
-Created INC/SR during &lt;repot period&gt;
-Trend
-&lt;Assignment group&gt;
-&lt;number or INC/SR&gt;
-&lt;number or INC/SR&gt;
-&lt;increase / decrease &gt;
-&lt;Assignment group&gt;
-&lt;number or INC/SR&gt;
-&lt;number or INC/SR&gt;
-IT SERVICE HEALTH: &lt;Project&gt; SERVICE VOLUME
-&lt;Diagram with all user’s and monitoring  incidents during reported period for a specific project (not including services covered  by client); including count of incidents and resolver assignment group
-4
-Business meaning:​
-These numbers represent unique tasks that came to each team and required attention and effort.​
-Proposed actions / decisions:​
-Analyzing volume trends correlating with major events;​
-Volume spikes after major events may indicate the need for further research of systemic root causes. &gt;
-IT SERVICE HEALTH: &lt;Project&gt; SERVICE VOLUME
-&lt;Diagram with ALL service requests (opened, resolved, closed) related  to a specific project &gt;
-Business meaning:​
-These numbers represent unique tasks that came to each team and required attention and effort.​
-Proposed actions / decisions:​
-Analyzing volume trends correlating with major events;​
-The number of increased/decreased tickers should be specified, and possible action items proposed.
-5
-6
-IT SERVICE HEALTH: &lt;Project/Team&gt; Incidents’ SLAs
-&lt;Examples&gt;
-Business meaning:​
-This stats will show whether Response and Resolution SLA are within SLA
-.​
-Proposed actions / decisions:​
-Analyzing SLA breaching
-Keep SLAs calibration and monitoring 
-SLA targets:
-&lt;Specify SLA targets for different priority levels &gt;
-&lt;Diagram with Average time for processing different types of priority levels incidents, should contain Average time for processing P1-P4 Incidents &gt;
-7
-IT SERVICE HEALTH: &lt;Project/team&gt; Incidents’ SLAs
-Business meaning:​
-This stats will show whether Response and Resolution SLA are within SLA for different priority levels
-Proposed actions / decisions:​
-Analyzing SLA breaching 
-Keep SLAs calibration and monitoring
-SLA targets:
-P1 &lt;should be specified for each one&gt;
-P2
-P3
-P4
-IT SERVICE HEALTH: &lt;Team/Project&gt; INCs’ and SRs’ SLA 
-8
-&lt;insert the following diagrams/ statistics charts:
-Average processing time for Service Requests, Resolution time for Service requests, Ticket resolution quality 
-Reassignment Compliance&gt;
-Business meaning:​
-This stats will show whether Average processing time of Service Requests is healthy; Reassignment Compliance and Ticket resolution quality (number of reopen)
-Proposed actions / decisions:​
-Analyzing service volume and propose action items if required
-IT SERVICE HEALTH: P0/P1 INCIDENTS
-&lt;Diagram with closed P0/P1 incidents grouped by resolver group&gt;
-P0/P1ticket
-SLA Breached
-Team
-Short Description
-RCA
-Prevention/Mitigation
-9
-Business meaning:​
-These numbers show how many tickets of different Priority are resolved by each group and may provide better understanding of the complexity of incidents,
-Actions / decisions:​
-Analyzing &lt;Analyzing trends may drive DEV effort prioritization of “code improvements” vs “feature development&gt;  &lt;stability of Code , structure , code&gt;
-IT SERVICE HEALTH: TICKET AGE
-&lt;Diagram with all open incidents grouped by Backlog time and diagram with all open incidents grouped by Backlog time and priority: grouped by the following statuses : New, In Progress, On Hold &gt;
-Tower (top 10)
-Age (1+ month)
-10
-Business meaning:​
-Displays the number of days tickets have been open in the system. &lt;open tasks, backlog&gt;
-Actions / decisions:​
-&lt;for future Problem Management &gt;
-IT SERVICE Customer Satisfaction (CSAT)
-&lt;Diagram with statistics and trend line&gt;
-11
-Business meaning:​
-Customer satisfaction and score that indicates how satisfied a customer is with a specific product, transaction, or interaction with a company
-Actions / decisions:​
-Regular monthly CSAT Review 
-SERVICE TOWER: SERVICE DESK
-&lt;only if required &gt;
-Service Volume
-&lt;D
-iagram with total number of Tickets created in ITSM tool vs Tickets accepted by L1 vs First Level resolution (FLR) tickets
-Service SLAs
-&lt;
-Service Desk first call resolution rate of  level 1Support (True/ falls)
-Response SLA for L1 team (True/ falls)
-Tickets Age
-&lt;diagram  with all Open INC+ SR grouped by Backlog time and State (Pending, Open, Work in progress) for L1 Team&gt;
-12
-Key Highlights 
-&lt;specify for reported period &gt;
-Critical issues 
-&lt;specify for reported period &gt;
-SLA target
-&lt;specify for reported period &gt;
-SERVICE TOWER: CHANGE MANAGEMENT 
-&lt;Diagram with all changes groups by statuses which are in ITSM tool&gt;
-13
-Business meaning 
-The number of RFCs
-Actions / decisions:​
-SERVICE TOWER :PROBLEM MANAGEMENT
-&lt;Diagram with all problems groups by statuses which are in ITSM tool&gt;
-14
-Business meaning 
-These numbers may provide better understanding of the complexity of incidents, stability of Code, and overall health of environment 
-Actions / decisions:​
-RISKS
-&lt;Mention all possible risks grouped by a separate tower of service (Service Desk, Change / INC/Problem Management , Different teams within the project )&gt;
-15
-Risks
-Risk Owner
-Impact 
-Description/Impact
-Mitigation
-IT SERVICE IMPROVEMENTS (CSIP)
-Short Description 
-Owner
-Impact
-Date
-16
-Completed This Month
-Planned Next Month 
-Short Description 
-Owner
-Impact
-Date
-THANK YOU!
-17
-</TemplatesTextContent>
-    <SubjectDoc xmlns="a17c10a8-bd22-4f4b-9c5c-c3dc02494c46">Template</SubjectDoc>
-    <FriendlyURL xmlns="a17c10a8-bd22-4f4b-9c5c-c3dc02494c46">files/templates-examples/global-delivery/monthly-review-report.pptx</FriendlyURL>
-    <BriefDescription xmlns="a17c10a8-bd22-4f4b-9c5c-c3dc02494c46">This template is related to Maintenance and Support Guideline and intended to be used for monthly status reporting of maintenance and support project.</BriefDescription>
-    <WorkStorage xmlns="a17c10a8-bd22-4f4b-9c5c-c3dc02494c46">
-      <Url>https://epam.sharepoint.com/sites/policy/work/Shared%20Documents/Work%20Product%20Templates/Continuous%20delivery/Maintenance%20and%20Support</Url>
-      <Description>/sites/policy/work/Shared Documents/Work Product Templates/Continuous delivery/Maintenance and Support</Description>
-    </WorkStorage>
-    <PageName xmlns="a17c10a8-bd22-4f4b-9c5c-c3dc02494c46">
-      <Url>https://policy.epam.com/pages/templates-examples/monthly-review-report</Url>
-      <Description>Template: Monthly Review Report</Description>
-    </PageName>
-    <OrganizationalUnit xmlns="a17c10a8-bd22-4f4b-9c5c-c3dc02494c46">
-      <Url>https://people.epam.com/network/1/8aec5375-fd5e-4dd5-aa02-b9d225a43413/structure</Url>
-      <Description>Delivery Management Office</Description>
-    </OrganizationalUnit>
-    <LocationCountry xmlns="a17c10a8-bd22-4f4b-9c5c-c3dc02494c46">
-      <Value>Global</Value>
-    </LocationCountry>
-    <LastApprovalDate xmlns="a17c10a8-bd22-4f4b-9c5c-c3dc02494c46">2022-12-20T21:00:00+00:00</LastApprovalDate>
-    <LastApproverName xmlns="a17c10a8-bd22-4f4b-9c5c-c3dc02494c46">Dmitry Makeev</LastApproverName>
-    <Standards xmlns="a17c10a8-bd22-4f4b-9c5c-c3dc02494c46">
-      <Value>###</Value>
-    </Standards>
-  </documentManagement>
-</p:properties>
-</file>
-
-<file path=customXml/item3.xml><?xml version="1.0" encoding="utf-8"?>
 <ct:contentTypeSchema xmlns:ct="http://schemas.microsoft.com/office/2006/metadata/contentType" xmlns:ma="http://schemas.microsoft.com/office/2006/metadata/properties/metaAttributes" ct:_="" ma:_="" ma:contentTypeName="EPAM Template" ma:contentTypeID="0x0101006F5799D5350E4747858630C5700DFDF00046CFA168D8AB1B4D937A734D2015792B" ma:contentTypeVersion="4" ma:contentTypeDescription="ECL EPAM Template CT" ma:contentTypeScope="" ma:versionID="3e46c49967fe6bc1ef07a9a4e4763266">
   <xsd:schema xmlns:xsd="http://www.w3.org/2001/XMLSchema" xmlns:xs="http://www.w3.org/2001/XMLSchema" xmlns:p="http://schemas.microsoft.com/office/2006/metadata/properties" xmlns:ns1="http://schemas.microsoft.com/sharepoint/v3" xmlns:ns2="a17c10a8-bd22-4f4b-9c5c-c3dc02494c46" xmlns:ns4="2f73596d-a490-4938-9ae7-6f2abd4edc7d" targetNamespace="http://schemas.microsoft.com/office/2006/metadata/properties" ma:root="true" ma:fieldsID="8dbb4452feda95d41a68f55f9310cbf0" ns1:_="" ns2:_="" ns4:_="">
     <xsd:import namespace="http://schemas.microsoft.com/sharepoint/v3"/>
@@ -50958,24 +50715,287 @@
 </ct:contentTypeSchema>
 </file>
 
+<file path=customXml/item3.xml><?xml version="1.0" encoding="utf-8"?>
+<p:properties xmlns:p="http://schemas.microsoft.com/office/2006/metadata/properties" xmlns:xsi="http://www.w3.org/2001/XMLSchema-instance" xmlns:pc="http://schemas.microsoft.com/office/infopath/2007/PartnerControls">
+  <documentManagement>
+    <_dlc_DocIdPersistId xmlns="2f73596d-a490-4938-9ae7-6f2abd4edc7d" xsi:nil="true"/>
+    <_dlc_DocIdUrl xmlns="2f73596d-a490-4938-9ae7-6f2abd4edc7d">
+      <Url>https://epam.sharepoint.com/sites/policy/_layouts/15/DocIdRedir.aspx?ID=EPAM-1788376749-106</Url>
+      <Description>EPAM-1788376749-106</Description>
+    </_dlc_DocIdUrl>
+    <_dlc_DocId xmlns="2f73596d-a490-4938-9ae7-6f2abd4edc7d">EPAM-1788376749-106</_dlc_DocId>
+    <Company xmlns="http://schemas.microsoft.com/sharepoint/v3" xsi:nil="true"/>
+    <DocumentArea xmlns="a17c10a8-bd22-4f4b-9c5c-c3dc02494c46">
+      <Value>Maintenance and Support</Value>
+    </DocumentArea>
+    <Subarea xmlns="a17c10a8-bd22-4f4b-9c5c-c3dc02494c46">###</Subarea>
+    <Document_x0020_Approver_x0020__x0028_position_x0029_ xmlns="a17c10a8-bd22-4f4b-9c5c-c3dc02494c46">Senior Director, Delivery Management Office</Document_x0020_Approver_x0020__x0028_position_x0029_>
+    <Document_x0020_Owner_x0020__x0028_position_x0029_ xmlns="a17c10a8-bd22-4f4b-9c5c-c3dc02494c46">Head of Global Delivery</Document_x0020_Owner_x0020__x0028_position_x0029_>
+    <EPAMDocumentID_x0020_ xmlns="a17c10a8-bd22-4f4b-9c5c-c3dc02494c46">EPAM_Template-1203</EPAMDocumentID_x0020_>
+    <TemplatesTextContent xmlns="a17c10a8-bd22-4f4b-9c5c-c3dc02494c46">IT SERVICES MONTHLY REVIEW 
+Reported period : &lt;month, year &gt;
+CONFIDENTIAL  |  
+© 
+2024
+ EPAM Systems, Inc.
+IT SERVICE HEALTH : SERVICE VOLUME
+&lt;Diagram with all user’s and monitoring  incidents during reported period ; including count of incidents and resolver assignment group&gt;
+IT SERVICE HEALTH : SERVICE VOLUME
+&lt;Diagram with all service requests during reported period, should include numbers of all INC and SRs tickets during this period.​
+Business meaning:​
+These numbers represent unique tasks that came to each team and required attention and effort.​
+Proposed actions / decisions:​
+Analyzing volume trends correlating with major events;​
+Volume spikes after major events may indicate the need for further research of systemic root causes. &gt;
+3
+Tower (top10)
+Created INC/SR during &lt;repot period&gt;
+Created INC/SR during &lt;repot period&gt;
+Trend
+&lt;Assignment group&gt;
+&lt;number or INC/SR&gt;
+&lt;number or INC/SR&gt;
+&lt;increase / decrease &gt;
+&lt;Assignment group&gt;
+&lt;number or INC/SR&gt;
+&lt;number or INC/SR&gt;
+IT SERVICE HEALTH: &lt;Project&gt; SERVICE VOLUME
+&lt;Diagram with all user’s and monitoring  incidents during reported period for a specific project (not including services covered  by client); including count of incidents and resolver assignment group
+4
+Business meaning:​
+These numbers represent unique tasks that came to each team and required attention and effort.​
+Proposed actions / decisions:​
+Analyzing volume trends correlating with major events;​
+Volume spikes after major events may indicate the need for further research of systemic root causes. &gt;
+IT SERVICE HEALTH: &lt;Project&gt; SERVICE VOLUME
+&lt;Diagram with ALL service requests (opened, resolved, closed) related  to a specific project &gt;
+Business meaning:​
+These numbers represent unique tasks that came to each team and required attention and effort.​
+Proposed actions / decisions:​
+Analyzing volume trends correlating with major events;​
+The number of increased/decreased tickers should be specified, and possible action items proposed.
+5
+6
+IT SERVICE HEALTH: &lt;Project/Team&gt; Incidents’ SLAs
+&lt;Examples&gt;
+Business meaning:​
+This stats will show whether Response and Resolution SLA are within SLA
+.​
+Proposed actions / decisions:​
+Analyzing SLA breaching
+Keep SLAs calibration and monitoring 
+SLA targets:
+&lt;Specify SLA targets for different priority levels &gt;
+&lt;Diagram with Average time for processing different types of priority levels incidents, should contain Average time for processing P1-P4 Incidents &gt;
+7
+IT SERVICE HEALTH: &lt;Project/team&gt; Incidents’ SLAs
+Business meaning:​
+This stats will show whether Response and Resolution SLA are within SLA for different priority levels
+Proposed actions / decisions:​
+Analyzing SLA breaching 
+Keep SLAs calibration and monitoring
+SLA targets:
+P1 &lt;should be specified for each one&gt;
+P2
+P3
+P4
+IT SERVICE HEALTH: &lt;Team/Project&gt; INCs’ and SRs’ SLA 
+8
+&lt;insert the following diagrams/ statistics charts:
+Average processing time for Service Requests, Resolution time for Service requests, Ticket resolution quality 
+Reassignment Compliance&gt;
+Business meaning:​
+This stats will show whether Average processing time of Service Requests is healthy; Reassignment Compliance and Ticket resolution quality (number of reopen)
+Proposed actions / decisions:​
+Analyzing service volume and propose action items if required
+IT SERVICE HEALTH: P0/P1 INCIDENTS
+&lt;Diagram with closed P0/P1 incidents grouped by resolver group&gt;
+P0/P1ticket
+SLA Breached
+Team
+Short Description
+RCA
+Prevention/Mitigation
+9
+Business meaning:​
+These numbers show how many tickets of different Priority are resolved by each group and may provide better understanding of the complexity of incidents,
+Actions / decisions:​
+Analyzing &lt;Analyzing trends may drive DEV effort prioritization of “code improvements” vs “feature development&gt;  &lt;stability of Code , structure , code&gt;
+IT SERVICE HEALTH: TICKET AGE
+&lt;Diagram with all open incidents grouped by Backlog time and diagram with all open incidents grouped by Backlog time and priority: grouped by the following statuses : New, In Progress, On Hold &gt;
+Tower (top 10)
+Age (1+ month)
+10
+Business meaning:​
+Displays the number of days tickets have been open in the system. &lt;open tasks, backlog&gt;
+Actions / decisions:​
+&lt;for future Problem Management &gt;
+IT SERVICE Customer Satisfaction (CSAT)
+&lt;Diagram with statistics and trend line&gt;
+11
+Business meaning:​
+Customer satisfaction and score that indicates how satisfied a customer is with a specific product, transaction, or interaction with a company
+Actions / decisions:​
+Regular monthly CSAT Review 
+SERVICE TOWER: SERVICE DESK
+&lt;only if required &gt;
+Service Volume
+&lt;D
+iagram with total number of Tickets created in ITSM tool vs Tickets accepted by L1 vs First Level resolution (FLR) tickets
+Service SLAs
+&lt;
+Service Desk first call resolution rate of  level 1Support (True/ falls)
+Response SLA for L1 team (True/ falls)
+Tickets Age
+&lt;diagram  with all Open INC+ SR grouped by Backlog time and State (Pending, Open, Work in progress) for L1 Team&gt;
+12
+Key Highlights 
+&lt;specify for reported period &gt;
+Critical issues 
+&lt;specify for reported period &gt;
+SLA target
+&lt;specify for reported period &gt;
+SERVICE TOWER: CHANGE MANAGEMENT 
+&lt;Diagram with all changes groups by statuses which are in ITSM tool&gt;
+13
+Business meaning 
+The number of RFCs
+Actions / decisions:​
+SERVICE TOWER :PROBLEM MANAGEMENT
+&lt;Diagram with all problems groups by statuses which are in ITSM tool&gt;
+14
+Business meaning 
+These numbers may provide better understanding of the complexity of incidents, stability of Code, and overall health of environment 
+Actions / decisions:​
+RISKS
+&lt;Mention all possible risks grouped by a separate tower of service (Service Desk, Change / INC/Problem Management , Different teams within the project )&gt;
+15
+Risks
+Risk Owner
+Impact 
+Description/Impact
+Mitigation
+IT SERVICE IMPROVEMENTS (CSIP)
+Short Description 
+Owner
+Impact
+Date
+16
+Completed This Month
+Planned Next Month 
+Short Description 
+Owner
+Impact
+Date
+THANK YOU!
+17
+</TemplatesTextContent>
+    <SubjectDoc xmlns="a17c10a8-bd22-4f4b-9c5c-c3dc02494c46">Template</SubjectDoc>
+    <FriendlyURL xmlns="a17c10a8-bd22-4f4b-9c5c-c3dc02494c46">files/templates-examples/global-delivery/monthly-review-report.pptx</FriendlyURL>
+    <BriefDescription xmlns="a17c10a8-bd22-4f4b-9c5c-c3dc02494c46">This template is related to Maintenance and Support Guideline and intended to be used for monthly status reporting of maintenance and support project.</BriefDescription>
+    <WorkStorage xmlns="a17c10a8-bd22-4f4b-9c5c-c3dc02494c46">
+      <Url>https://epam.sharepoint.com/sites/policy/work/Shared%20Documents/Work%20Product%20Templates/Continuous%20delivery/Maintenance%20and%20Support</Url>
+      <Description>/sites/policy/work/Shared Documents/Work Product Templates/Continuous delivery/Maintenance and Support</Description>
+    </WorkStorage>
+    <PageName xmlns="a17c10a8-bd22-4f4b-9c5c-c3dc02494c46">
+      <Url>https://policy.epam.com/pages/templates-examples/monthly-review-report</Url>
+      <Description>Template: Monthly Review Report</Description>
+    </PageName>
+    <OrganizationalUnit xmlns="a17c10a8-bd22-4f4b-9c5c-c3dc02494c46">
+      <Url>https://people.epam.com/network/1/8aec5375-fd5e-4dd5-aa02-b9d225a43413/structure</Url>
+      <Description>Delivery Management Office</Description>
+    </OrganizationalUnit>
+    <LocationCountry xmlns="a17c10a8-bd22-4f4b-9c5c-c3dc02494c46">
+      <Value>Global</Value>
+    </LocationCountry>
+    <LastApprovalDate xmlns="a17c10a8-bd22-4f4b-9c5c-c3dc02494c46">2022-12-20T21:00:00+00:00</LastApprovalDate>
+    <LastApproverName xmlns="a17c10a8-bd22-4f4b-9c5c-c3dc02494c46">Dmitry Makeev</LastApproverName>
+    <Standards xmlns="a17c10a8-bd22-4f4b-9c5c-c3dc02494c46">
+      <Value>###</Value>
+    </Standards>
+  </documentManagement>
+</p:properties>
+</file>
+
 <file path=customXml/item4.xml><?xml version="1.0" encoding="utf-8"?>
 <?mso-contentType ?>
-<FormTemplates xmlns="http://schemas.microsoft.com/sharepoint/v3/contenttype/forms">
-  <Display>DocumentLibraryForm</Display>
-  <Edit>DocumentLibraryForm</Edit>
-  <New>DocumentLibraryForm</New>
-</FormTemplates>
+<spe:Receivers xmlns:spe="http://schemas.microsoft.com/sharepoint/events">
+  <Receiver>
+    <Name>Document ID Generator</Name>
+    <Synchronization>Synchronous</Synchronization>
+    <Type>10001</Type>
+    <SequenceNumber>1000</SequenceNumber>
+    <Url/>
+    <Assembly>Microsoft.Office.DocumentManagement, Version=16.0.0.0, Culture=neutral, PublicKeyToken=71e9bce111e9429c</Assembly>
+    <Class>Microsoft.Office.DocumentManagement.Internal.DocIdHandler</Class>
+    <Data/>
+    <Filter/>
+  </Receiver>
+  <Receiver>
+    <Name>Document ID Generator</Name>
+    <Synchronization>Synchronous</Synchronization>
+    <Type>10002</Type>
+    <SequenceNumber>1001</SequenceNumber>
+    <Url/>
+    <Assembly>Microsoft.Office.DocumentManagement, Version=16.0.0.0, Culture=neutral, PublicKeyToken=71e9bce111e9429c</Assembly>
+    <Class>Microsoft.Office.DocumentManagement.Internal.DocIdHandler</Class>
+    <Data/>
+    <Filter/>
+  </Receiver>
+  <Receiver>
+    <Name>Document ID Generator</Name>
+    <Synchronization>Synchronous</Synchronization>
+    <Type>10004</Type>
+    <SequenceNumber>1002</SequenceNumber>
+    <Url/>
+    <Assembly>Microsoft.Office.DocumentManagement, Version=16.0.0.0, Culture=neutral, PublicKeyToken=71e9bce111e9429c</Assembly>
+    <Class>Microsoft.Office.DocumentManagement.Internal.DocIdHandler</Class>
+    <Data/>
+    <Filter/>
+  </Receiver>
+  <Receiver>
+    <Name>Document ID Generator</Name>
+    <Synchronization>Synchronous</Synchronization>
+    <Type>10006</Type>
+    <SequenceNumber>1003</SequenceNumber>
+    <Url/>
+    <Assembly>Microsoft.Office.DocumentManagement, Version=16.0.0.0, Culture=neutral, PublicKeyToken=71e9bce111e9429c</Assembly>
+    <Class>Microsoft.Office.DocumentManagement.Internal.DocIdHandler</Class>
+    <Data/>
+    <Filter/>
+  </Receiver>
+</spe:Receivers>
 </file>
 
 <file path=customXml/itemProps1.xml><?xml version="1.0" encoding="utf-8"?>
-<ds:datastoreItem xmlns:ds="http://schemas.openxmlformats.org/officeDocument/2006/customXml" ds:itemID="{4A6F74FC-DCE4-4FAD-B152-022B257C5C9F}">
+<ds:datastoreItem xmlns:ds="http://schemas.openxmlformats.org/officeDocument/2006/customXml" ds:itemID="{7C112C0A-7F3A-4E28-80B1-4B14EB4F54BD}">
   <ds:schemaRefs>
-    <ds:schemaRef ds:uri="http://schemas.microsoft.com/sharepoint/events"/>
+    <ds:schemaRef ds:uri="http://schemas.microsoft.com/sharepoint/v3/contenttype/forms"/>
   </ds:schemaRefs>
 </ds:datastoreItem>
 </file>
 
 <file path=customXml/itemProps2.xml><?xml version="1.0" encoding="utf-8"?>
+<ds:datastoreItem xmlns:ds="http://schemas.openxmlformats.org/officeDocument/2006/customXml" ds:itemID="{1A413D99-DCF0-4BFE-8F14-77623FB180E9}">
+  <ds:schemaRefs>
+    <ds:schemaRef ds:uri="http://schemas.microsoft.com/office/2006/metadata/contentType"/>
+    <ds:schemaRef ds:uri="http://schemas.microsoft.com/office/2006/metadata/properties/metaAttributes"/>
+    <ds:schemaRef ds:uri="http://www.w3.org/2001/XMLSchema"/>
+    <ds:schemaRef ds:uri="http://schemas.microsoft.com/office/2006/metadata/properties"/>
+    <ds:schemaRef ds:uri="http://schemas.microsoft.com/sharepoint/v3"/>
+    <ds:schemaRef ds:uri="a17c10a8-bd22-4f4b-9c5c-c3dc02494c46"/>
+    <ds:schemaRef ds:uri="2f73596d-a490-4938-9ae7-6f2abd4edc7d"/>
+    <ds:schemaRef ds:uri="http://schemas.microsoft.com/office/2006/documentManagement/types"/>
+    <ds:schemaRef ds:uri="http://schemas.microsoft.com/office/infopath/2007/PartnerControls"/>
+    <ds:schemaRef ds:uri="http://schemas.openxmlformats.org/package/2006/metadata/core-properties"/>
+    <ds:schemaRef ds:uri="http://purl.org/dc/elements/1.1/"/>
+    <ds:schemaRef ds:uri="http://purl.org/dc/terms/"/>
+    <ds:schemaRef ds:uri="http://schemas.microsoft.com/internal/obd"/>
+  </ds:schemaRefs>
+</ds:datastoreItem>
+</file>
+
+<file path=customXml/itemProps3.xml><?xml version="1.0" encoding="utf-8"?>
 <ds:datastoreItem xmlns:ds="http://schemas.openxmlformats.org/officeDocument/2006/customXml" ds:itemID="{A50FA2CC-35CC-4D88-B54E-498208D7C745}">
   <ds:schemaRefs>
     <ds:schemaRef ds:uri="http://purl.org/dc/elements/1.1/"/>
@@ -50997,30 +51017,10 @@
 </ds:datastoreItem>
 </file>
 
-<file path=customXml/itemProps3.xml><?xml version="1.0" encoding="utf-8"?>
-<ds:datastoreItem xmlns:ds="http://schemas.openxmlformats.org/officeDocument/2006/customXml" ds:itemID="{1A413D99-DCF0-4BFE-8F14-77623FB180E9}">
+<file path=customXml/itemProps4.xml><?xml version="1.0" encoding="utf-8"?>
+<ds:datastoreItem xmlns:ds="http://schemas.openxmlformats.org/officeDocument/2006/customXml" ds:itemID="{4A6F74FC-DCE4-4FAD-B152-022B257C5C9F}">
   <ds:schemaRefs>
-    <ds:schemaRef ds:uri="http://schemas.microsoft.com/office/2006/metadata/contentType"/>
-    <ds:schemaRef ds:uri="http://schemas.microsoft.com/office/2006/metadata/properties/metaAttributes"/>
-    <ds:schemaRef ds:uri="http://www.w3.org/2001/XMLSchema"/>
-    <ds:schemaRef ds:uri="http://schemas.microsoft.com/office/2006/metadata/properties"/>
-    <ds:schemaRef ds:uri="http://schemas.microsoft.com/sharepoint/v3"/>
-    <ds:schemaRef ds:uri="a17c10a8-bd22-4f4b-9c5c-c3dc02494c46"/>
-    <ds:schemaRef ds:uri="2f73596d-a490-4938-9ae7-6f2abd4edc7d"/>
-    <ds:schemaRef ds:uri="http://schemas.microsoft.com/office/2006/documentManagement/types"/>
-    <ds:schemaRef ds:uri="http://schemas.microsoft.com/office/infopath/2007/PartnerControls"/>
-    <ds:schemaRef ds:uri="http://schemas.openxmlformats.org/package/2006/metadata/core-properties"/>
-    <ds:schemaRef ds:uri="http://purl.org/dc/elements/1.1/"/>
-    <ds:schemaRef ds:uri="http://purl.org/dc/terms/"/>
-    <ds:schemaRef ds:uri="http://schemas.microsoft.com/internal/obd"/>
-  </ds:schemaRefs>
-</ds:datastoreItem>
-</file>
-
-<file path=customXml/itemProps4.xml><?xml version="1.0" encoding="utf-8"?>
-<ds:datastoreItem xmlns:ds="http://schemas.openxmlformats.org/officeDocument/2006/customXml" ds:itemID="{7C112C0A-7F3A-4E28-80B1-4B14EB4F54BD}">
-  <ds:schemaRefs>
-    <ds:schemaRef ds:uri="http://schemas.microsoft.com/sharepoint/v3/contenttype/forms"/>
+    <ds:schemaRef ds:uri="http://schemas.microsoft.com/sharepoint/events"/>
   </ds:schemaRefs>
 </ds:datastoreItem>
 </file>
</xml_diff>